<commit_message>
Corrected some power point wording
</commit_message>
<xml_diff>
--- a/assignment_1/task2/Task2_report.pptx
+++ b/assignment_1/task2/Task2_report.pptx
@@ -1601,7 +1601,7 @@
           <a:p>
             <a:fld id="{4AAD347D-5ACD-4C99-B74B-A9C85AD731AF}" type="datetimeFigureOut">
               <a:rPr lang="en-US" smtClean="0"/>
-              <a:t>3/25/2026</a:t>
+              <a:t>3/28/2026</a:t>
             </a:fld>
             <a:endParaRPr lang="en-US" dirty="0"/>
           </a:p>
@@ -1643,7 +1643,7 @@
           <a:p>
             <a:fld id="{D57F1E4F-1CFF-5643-939E-02111984F565}" type="slidenum">
               <a:rPr lang="en-US" smtClean="0"/>
-              <a:t>‹#›</a:t>
+              <a:t>‹nº›</a:t>
             </a:fld>
             <a:endParaRPr lang="en-US" dirty="0"/>
           </a:p>
@@ -1883,7 +1883,7 @@
           <a:p>
             <a:fld id="{4509A250-FF31-4206-8172-F9D3106AACB1}" type="datetimeFigureOut">
               <a:rPr lang="en-US" smtClean="0"/>
-              <a:t>3/25/2026</a:t>
+              <a:t>3/28/2026</a:t>
             </a:fld>
             <a:endParaRPr lang="en-US" dirty="0"/>
           </a:p>
@@ -1925,7 +1925,7 @@
           <a:p>
             <a:fld id="{D57F1E4F-1CFF-5643-939E-02111984F565}" type="slidenum">
               <a:rPr lang="en-US" smtClean="0"/>
-              <a:t>‹#›</a:t>
+              <a:t>‹nº›</a:t>
             </a:fld>
             <a:endParaRPr lang="en-US" dirty="0"/>
           </a:p>
@@ -2076,7 +2076,7 @@
           <a:p>
             <a:fld id="{4509A250-FF31-4206-8172-F9D3106AACB1}" type="datetimeFigureOut">
               <a:rPr lang="en-US" smtClean="0"/>
-              <a:t>3/25/2026</a:t>
+              <a:t>3/28/2026</a:t>
             </a:fld>
             <a:endParaRPr lang="en-US" dirty="0"/>
           </a:p>
@@ -2118,7 +2118,7 @@
           <a:p>
             <a:fld id="{D57F1E4F-1CFF-5643-939E-02111984F565}" type="slidenum">
               <a:rPr lang="en-US" smtClean="0"/>
-              <a:t>‹#›</a:t>
+              <a:t>‹nº›</a:t>
             </a:fld>
             <a:endParaRPr lang="en-US" dirty="0"/>
           </a:p>
@@ -2338,7 +2338,7 @@
           <a:p>
             <a:fld id="{4AAD347D-5ACD-4C99-B74B-A9C85AD731AF}" type="datetimeFigureOut">
               <a:rPr lang="en-US" smtClean="0"/>
-              <a:t>3/25/2026</a:t>
+              <a:t>3/28/2026</a:t>
             </a:fld>
             <a:endParaRPr lang="en-US" dirty="0"/>
           </a:p>
@@ -2380,7 +2380,7 @@
           <a:p>
             <a:fld id="{D57F1E4F-1CFF-5643-939E-02111984F565}" type="slidenum">
               <a:rPr lang="en-US" smtClean="0"/>
-              <a:t>‹#›</a:t>
+              <a:t>‹nº›</a:t>
             </a:fld>
             <a:endParaRPr lang="en-US" dirty="0"/>
           </a:p>
@@ -2765,7 +2765,7 @@
           <a:p>
             <a:fld id="{4AAD347D-5ACD-4C99-B74B-A9C85AD731AF}" type="datetimeFigureOut">
               <a:rPr lang="en-US" smtClean="0"/>
-              <a:t>3/25/2026</a:t>
+              <a:t>3/28/2026</a:t>
             </a:fld>
             <a:endParaRPr lang="en-US" dirty="0"/>
           </a:p>
@@ -2807,7 +2807,7 @@
           <a:p>
             <a:fld id="{D57F1E4F-1CFF-5643-939E-02111984F565}" type="slidenum">
               <a:rPr lang="en-US" smtClean="0"/>
-              <a:t>‹#›</a:t>
+              <a:t>‹nº›</a:t>
             </a:fld>
             <a:endParaRPr lang="en-US" dirty="0"/>
           </a:p>
@@ -3312,7 +3312,7 @@
           <a:p>
             <a:fld id="{4509A250-FF31-4206-8172-F9D3106AACB1}" type="datetimeFigureOut">
               <a:rPr lang="en-US" smtClean="0"/>
-              <a:t>3/25/2026</a:t>
+              <a:t>3/28/2026</a:t>
             </a:fld>
             <a:endParaRPr lang="en-US" dirty="0"/>
           </a:p>
@@ -3354,7 +3354,7 @@
           <a:p>
             <a:fld id="{D57F1E4F-1CFF-5643-939E-02111984F565}" type="slidenum">
               <a:rPr lang="en-US" smtClean="0"/>
-              <a:t>‹#›</a:t>
+              <a:t>‹nº›</a:t>
             </a:fld>
             <a:endParaRPr lang="en-US" dirty="0"/>
           </a:p>
@@ -4144,7 +4144,7 @@
           <a:p>
             <a:fld id="{4509A250-FF31-4206-8172-F9D3106AACB1}" type="datetimeFigureOut">
               <a:rPr lang="en-US" smtClean="0"/>
-              <a:t>3/25/2026</a:t>
+              <a:t>3/28/2026</a:t>
             </a:fld>
             <a:endParaRPr lang="en-US" dirty="0"/>
           </a:p>
@@ -4186,7 +4186,7 @@
           <a:p>
             <a:fld id="{D57F1E4F-1CFF-5643-939E-02111984F565}" type="slidenum">
               <a:rPr lang="en-US" smtClean="0"/>
-              <a:t>‹#›</a:t>
+              <a:t>‹nº›</a:t>
             </a:fld>
             <a:endParaRPr lang="en-US" dirty="0"/>
           </a:p>
@@ -4315,7 +4315,7 @@
           <a:p>
             <a:fld id="{4509A250-FF31-4206-8172-F9D3106AACB1}" type="datetimeFigureOut">
               <a:rPr lang="en-US" smtClean="0"/>
-              <a:t>3/25/2026</a:t>
+              <a:t>3/28/2026</a:t>
             </a:fld>
             <a:endParaRPr lang="en-US" dirty="0"/>
           </a:p>
@@ -4357,7 +4357,7 @@
           <a:p>
             <a:fld id="{D57F1E4F-1CFF-5643-939E-02111984F565}" type="slidenum">
               <a:rPr lang="en-US" smtClean="0"/>
-              <a:t>‹#›</a:t>
+              <a:t>‹nº›</a:t>
             </a:fld>
             <a:endParaRPr lang="en-US" dirty="0"/>
           </a:p>
@@ -4496,7 +4496,7 @@
           <a:p>
             <a:fld id="{4509A250-FF31-4206-8172-F9D3106AACB1}" type="datetimeFigureOut">
               <a:rPr lang="en-US" smtClean="0"/>
-              <a:t>3/25/2026</a:t>
+              <a:t>3/28/2026</a:t>
             </a:fld>
             <a:endParaRPr lang="en-US" dirty="0"/>
           </a:p>
@@ -4538,7 +4538,7 @@
           <a:p>
             <a:fld id="{D57F1E4F-1CFF-5643-939E-02111984F565}" type="slidenum">
               <a:rPr lang="en-US" smtClean="0"/>
-              <a:t>‹#›</a:t>
+              <a:t>‹nº›</a:t>
             </a:fld>
             <a:endParaRPr lang="en-US" dirty="0"/>
           </a:p>
@@ -4764,7 +4764,7 @@
           <a:p>
             <a:fld id="{4AAD347D-5ACD-4C99-B74B-A9C85AD731AF}" type="datetimeFigureOut">
               <a:rPr lang="en-US" smtClean="0"/>
-              <a:t>3/25/2026</a:t>
+              <a:t>3/28/2026</a:t>
             </a:fld>
             <a:endParaRPr lang="en-US" dirty="0"/>
           </a:p>
@@ -4806,7 +4806,7 @@
           <a:p>
             <a:fld id="{D57F1E4F-1CFF-5643-939E-02111984F565}" type="slidenum">
               <a:rPr lang="en-US" smtClean="0"/>
-              <a:t>‹#›</a:t>
+              <a:t>‹nº›</a:t>
             </a:fld>
             <a:endParaRPr lang="en-US" dirty="0"/>
           </a:p>
@@ -4935,7 +4935,7 @@
           <a:p>
             <a:fld id="{4509A250-FF31-4206-8172-F9D3106AACB1}" type="datetimeFigureOut">
               <a:rPr lang="en-US" smtClean="0"/>
-              <a:t>3/25/2026</a:t>
+              <a:t>3/28/2026</a:t>
             </a:fld>
             <a:endParaRPr lang="en-US" dirty="0"/>
           </a:p>
@@ -4977,7 +4977,7 @@
           <a:p>
             <a:fld id="{D57F1E4F-1CFF-5643-939E-02111984F565}" type="slidenum">
               <a:rPr lang="en-US" smtClean="0"/>
-              <a:t>‹#›</a:t>
+              <a:t>‹nº›</a:t>
             </a:fld>
             <a:endParaRPr lang="en-US" dirty="0"/>
           </a:p>
@@ -5141,7 +5141,7 @@
           <a:p>
             <a:fld id="{4AAD347D-5ACD-4C99-B74B-A9C85AD731AF}" type="datetimeFigureOut">
               <a:rPr lang="en-US" smtClean="0"/>
-              <a:t>3/25/2026</a:t>
+              <a:t>3/28/2026</a:t>
             </a:fld>
             <a:endParaRPr lang="en-US" dirty="0"/>
           </a:p>
@@ -5183,7 +5183,7 @@
           <a:p>
             <a:fld id="{D57F1E4F-1CFF-5643-939E-02111984F565}" type="slidenum">
               <a:rPr lang="en-US" smtClean="0"/>
-              <a:t>‹#›</a:t>
+              <a:t>‹nº›</a:t>
             </a:fld>
             <a:endParaRPr lang="en-US" dirty="0"/>
           </a:p>
@@ -5422,7 +5422,7 @@
           <a:p>
             <a:fld id="{9796027F-7875-4030-9381-8BD8C4F21935}" type="datetimeFigureOut">
               <a:rPr lang="en-US" smtClean="0"/>
-              <a:t>3/25/2026</a:t>
+              <a:t>3/28/2026</a:t>
             </a:fld>
             <a:endParaRPr lang="en-US" dirty="0"/>
           </a:p>
@@ -5464,7 +5464,7 @@
           <a:p>
             <a:fld id="{D57F1E4F-1CFF-5643-939E-02111984F565}" type="slidenum">
               <a:rPr lang="en-US" smtClean="0"/>
-              <a:t>‹#›</a:t>
+              <a:t>‹nº›</a:t>
             </a:fld>
             <a:endParaRPr lang="en-US" dirty="0"/>
           </a:p>
@@ -5690,7 +5690,7 @@
           <a:p>
             <a:fld id="{4AAD347D-5ACD-4C99-B74B-A9C85AD731AF}" type="datetimeFigureOut">
               <a:rPr lang="en-US" smtClean="0"/>
-              <a:t>3/25/2026</a:t>
+              <a:t>3/28/2026</a:t>
             </a:fld>
             <a:endParaRPr lang="en-US" dirty="0"/>
           </a:p>
@@ -5732,7 +5732,7 @@
           <a:p>
             <a:fld id="{D57F1E4F-1CFF-5643-939E-02111984F565}" type="slidenum">
               <a:rPr lang="en-US" smtClean="0"/>
-              <a:t>‹#›</a:t>
+              <a:t>‹nº›</a:t>
             </a:fld>
             <a:endParaRPr lang="en-US" dirty="0"/>
           </a:p>
@@ -6106,7 +6106,7 @@
           <a:p>
             <a:fld id="{4AAD347D-5ACD-4C99-B74B-A9C85AD731AF}" type="datetimeFigureOut">
               <a:rPr lang="en-US" smtClean="0"/>
-              <a:t>3/25/2026</a:t>
+              <a:t>3/28/2026</a:t>
             </a:fld>
             <a:endParaRPr lang="en-US" dirty="0"/>
           </a:p>
@@ -6148,7 +6148,7 @@
           <a:p>
             <a:fld id="{D57F1E4F-1CFF-5643-939E-02111984F565}" type="slidenum">
               <a:rPr lang="en-US" smtClean="0"/>
-              <a:t>‹#›</a:t>
+              <a:t>‹nº›</a:t>
             </a:fld>
             <a:endParaRPr lang="en-US" dirty="0"/>
           </a:p>
@@ -6255,7 +6255,7 @@
           <a:p>
             <a:fld id="{4509A250-FF31-4206-8172-F9D3106AACB1}" type="datetimeFigureOut">
               <a:rPr lang="en-US" smtClean="0"/>
-              <a:t>3/25/2026</a:t>
+              <a:t>3/28/2026</a:t>
             </a:fld>
             <a:endParaRPr lang="en-US" dirty="0"/>
           </a:p>
@@ -6297,7 +6297,7 @@
           <a:p>
             <a:fld id="{D57F1E4F-1CFF-5643-939E-02111984F565}" type="slidenum">
               <a:rPr lang="en-US" smtClean="0"/>
-              <a:t>‹#›</a:t>
+              <a:t>‹nº›</a:t>
             </a:fld>
             <a:endParaRPr lang="en-US" dirty="0"/>
           </a:p>
@@ -6381,7 +6381,7 @@
           <a:p>
             <a:fld id="{4509A250-FF31-4206-8172-F9D3106AACB1}" type="datetimeFigureOut">
               <a:rPr lang="en-US" smtClean="0"/>
-              <a:t>3/25/2026</a:t>
+              <a:t>3/28/2026</a:t>
             </a:fld>
             <a:endParaRPr lang="en-US" dirty="0"/>
           </a:p>
@@ -6423,7 +6423,7 @@
           <a:p>
             <a:fld id="{D57F1E4F-1CFF-5643-939E-02111984F565}" type="slidenum">
               <a:rPr lang="en-US" smtClean="0"/>
-              <a:t>‹#›</a:t>
+              <a:t>‹nº›</a:t>
             </a:fld>
             <a:endParaRPr lang="en-US" dirty="0"/>
           </a:p>
@@ -6661,7 +6661,7 @@
           <a:p>
             <a:fld id="{4AAD347D-5ACD-4C99-B74B-A9C85AD731AF}" type="datetimeFigureOut">
               <a:rPr lang="en-US" smtClean="0"/>
-              <a:t>3/25/2026</a:t>
+              <a:t>3/28/2026</a:t>
             </a:fld>
             <a:endParaRPr lang="en-US" dirty="0"/>
           </a:p>
@@ -6703,7 +6703,7 @@
           <a:p>
             <a:fld id="{D57F1E4F-1CFF-5643-939E-02111984F565}" type="slidenum">
               <a:rPr lang="en-US" smtClean="0"/>
-              <a:t>‹#›</a:t>
+              <a:t>‹nº›</a:t>
             </a:fld>
             <a:endParaRPr lang="en-US" dirty="0"/>
           </a:p>
@@ -6974,7 +6974,7 @@
           <a:p>
             <a:fld id="{4509A250-FF31-4206-8172-F9D3106AACB1}" type="datetimeFigureOut">
               <a:rPr lang="en-US" smtClean="0"/>
-              <a:t>3/25/2026</a:t>
+              <a:t>3/28/2026</a:t>
             </a:fld>
             <a:endParaRPr lang="en-US" dirty="0"/>
           </a:p>
@@ -7016,7 +7016,7 @@
           <a:p>
             <a:fld id="{D57F1E4F-1CFF-5643-939E-02111984F565}" type="slidenum">
               <a:rPr lang="en-US" smtClean="0"/>
-              <a:t>‹#›</a:t>
+              <a:t>‹nº›</a:t>
             </a:fld>
             <a:endParaRPr lang="en-US" dirty="0"/>
           </a:p>
@@ -7287,7 +7287,7 @@
           <a:p>
             <a:fld id="{4509A250-FF31-4206-8172-F9D3106AACB1}" type="datetimeFigureOut">
               <a:rPr lang="en-US" smtClean="0"/>
-              <a:t>3/25/2026</a:t>
+              <a:t>3/28/2026</a:t>
             </a:fld>
             <a:endParaRPr lang="en-US" dirty="0"/>
           </a:p>
@@ -7329,7 +7329,7 @@
           <a:p>
             <a:fld id="{D57F1E4F-1CFF-5643-939E-02111984F565}" type="slidenum">
               <a:rPr lang="en-US" smtClean="0"/>
-              <a:t>‹#›</a:t>
+              <a:t>‹nº›</a:t>
             </a:fld>
             <a:endParaRPr lang="en-US" dirty="0"/>
           </a:p>
@@ -7510,7 +7510,7 @@
           <a:p>
             <a:fld id="{4509A250-FF31-4206-8172-F9D3106AACB1}" type="datetimeFigureOut">
               <a:rPr lang="en-US" smtClean="0"/>
-              <a:t>3/25/2026</a:t>
+              <a:t>3/28/2026</a:t>
             </a:fld>
             <a:endParaRPr lang="en-US" dirty="0"/>
           </a:p>
@@ -7552,7 +7552,7 @@
           <a:p>
             <a:fld id="{D57F1E4F-1CFF-5643-939E-02111984F565}" type="slidenum">
               <a:rPr lang="en-US" smtClean="0"/>
-              <a:t>‹#›</a:t>
+              <a:t>‹nº›</a:t>
             </a:fld>
             <a:endParaRPr lang="en-US" dirty="0"/>
           </a:p>
@@ -7768,7 +7768,7 @@
           <a:p>
             <a:fld id="{9796027F-7875-4030-9381-8BD8C4F21935}" type="datetimeFigureOut">
               <a:rPr lang="en-US" smtClean="0"/>
-              <a:t>3/25/2026</a:t>
+              <a:t>3/28/2026</a:t>
             </a:fld>
             <a:endParaRPr lang="en-US" dirty="0"/>
           </a:p>
@@ -7810,7 +7810,7 @@
           <a:p>
             <a:fld id="{D57F1E4F-1CFF-5643-939E-02111984F565}" type="slidenum">
               <a:rPr lang="en-US" smtClean="0"/>
-              <a:t>‹#›</a:t>
+              <a:t>‹nº›</a:t>
             </a:fld>
             <a:endParaRPr lang="en-US" dirty="0"/>
           </a:p>
@@ -8060,7 +8060,7 @@
           <a:p>
             <a:fld id="{4AAD347D-5ACD-4C99-B74B-A9C85AD731AF}" type="datetimeFigureOut">
               <a:rPr lang="en-US" smtClean="0"/>
-              <a:t>3/25/2026</a:t>
+              <a:t>3/28/2026</a:t>
             </a:fld>
             <a:endParaRPr lang="en-US" dirty="0"/>
           </a:p>
@@ -8102,7 +8102,7 @@
           <a:p>
             <a:fld id="{D57F1E4F-1CFF-5643-939E-02111984F565}" type="slidenum">
               <a:rPr lang="en-US" smtClean="0"/>
-              <a:t>‹#›</a:t>
+              <a:t>‹nº›</a:t>
             </a:fld>
             <a:endParaRPr lang="en-US" dirty="0"/>
           </a:p>
@@ -8515,7 +8515,7 @@
           <a:p>
             <a:fld id="{4AAD347D-5ACD-4C99-B74B-A9C85AD731AF}" type="datetimeFigureOut">
               <a:rPr lang="en-US" smtClean="0"/>
-              <a:t>3/25/2026</a:t>
+              <a:t>3/28/2026</a:t>
             </a:fld>
             <a:endParaRPr lang="en-US" dirty="0"/>
           </a:p>
@@ -8557,7 +8557,7 @@
           <a:p>
             <a:fld id="{D57F1E4F-1CFF-5643-939E-02111984F565}" type="slidenum">
               <a:rPr lang="en-US" smtClean="0"/>
-              <a:t>‹#›</a:t>
+              <a:t>‹nº›</a:t>
             </a:fld>
             <a:endParaRPr lang="en-US" dirty="0"/>
           </a:p>
@@ -9092,7 +9092,7 @@
           <a:p>
             <a:fld id="{4509A250-FF31-4206-8172-F9D3106AACB1}" type="datetimeFigureOut">
               <a:rPr lang="en-US" smtClean="0"/>
-              <a:t>3/25/2026</a:t>
+              <a:t>3/28/2026</a:t>
             </a:fld>
             <a:endParaRPr lang="en-US" dirty="0"/>
           </a:p>
@@ -9134,7 +9134,7 @@
           <a:p>
             <a:fld id="{D57F1E4F-1CFF-5643-939E-02111984F565}" type="slidenum">
               <a:rPr lang="en-US" smtClean="0"/>
-              <a:t>‹#›</a:t>
+              <a:t>‹nº›</a:t>
             </a:fld>
             <a:endParaRPr lang="en-US" dirty="0"/>
           </a:p>
@@ -9945,7 +9945,7 @@
           <a:p>
             <a:fld id="{4509A250-FF31-4206-8172-F9D3106AACB1}" type="datetimeFigureOut">
               <a:rPr lang="en-US" smtClean="0"/>
-              <a:t>3/25/2026</a:t>
+              <a:t>3/28/2026</a:t>
             </a:fld>
             <a:endParaRPr lang="en-US" dirty="0"/>
           </a:p>
@@ -9987,7 +9987,7 @@
           <a:p>
             <a:fld id="{D57F1E4F-1CFF-5643-939E-02111984F565}" type="slidenum">
               <a:rPr lang="en-US" smtClean="0"/>
-              <a:t>‹#›</a:t>
+              <a:t>‹nº›</a:t>
             </a:fld>
             <a:endParaRPr lang="en-US" dirty="0"/>
           </a:p>
@@ -10151,7 +10151,7 @@
           <a:p>
             <a:fld id="{4AAD347D-5ACD-4C99-B74B-A9C85AD731AF}" type="datetimeFigureOut">
               <a:rPr lang="en-US" smtClean="0"/>
-              <a:t>3/25/2026</a:t>
+              <a:t>3/28/2026</a:t>
             </a:fld>
             <a:endParaRPr lang="en-US" dirty="0"/>
           </a:p>
@@ -10193,7 +10193,7 @@
           <a:p>
             <a:fld id="{D57F1E4F-1CFF-5643-939E-02111984F565}" type="slidenum">
               <a:rPr lang="en-US" smtClean="0"/>
-              <a:t>‹#›</a:t>
+              <a:t>‹nº›</a:t>
             </a:fld>
             <a:endParaRPr lang="en-US" dirty="0"/>
           </a:p>
@@ -10366,7 +10366,7 @@
           <a:p>
             <a:fld id="{4AAD347D-5ACD-4C99-B74B-A9C85AD731AF}" type="datetimeFigureOut">
               <a:rPr lang="en-US" smtClean="0"/>
-              <a:t>3/25/2026</a:t>
+              <a:t>3/28/2026</a:t>
             </a:fld>
             <a:endParaRPr lang="en-US" dirty="0"/>
           </a:p>
@@ -10408,7 +10408,7 @@
           <a:p>
             <a:fld id="{D57F1E4F-1CFF-5643-939E-02111984F565}" type="slidenum">
               <a:rPr lang="en-US" smtClean="0"/>
-              <a:t>‹#›</a:t>
+              <a:t>‹nº›</a:t>
             </a:fld>
             <a:endParaRPr lang="en-US" dirty="0"/>
           </a:p>
@@ -10634,7 +10634,7 @@
           <a:p>
             <a:fld id="{9796027F-7875-4030-9381-8BD8C4F21935}" type="datetimeFigureOut">
               <a:rPr lang="en-US" smtClean="0"/>
-              <a:t>3/25/2026</a:t>
+              <a:t>3/28/2026</a:t>
             </a:fld>
             <a:endParaRPr lang="en-US" dirty="0"/>
           </a:p>
@@ -10676,7 +10676,7 @@
           <a:p>
             <a:fld id="{D57F1E4F-1CFF-5643-939E-02111984F565}" type="slidenum">
               <a:rPr lang="en-US" smtClean="0"/>
-              <a:t>‹#›</a:t>
+              <a:t>‹nº›</a:t>
             </a:fld>
             <a:endParaRPr lang="en-US" dirty="0"/>
           </a:p>
@@ -11028,7 +11028,7 @@
           <a:p>
             <a:fld id="{9796027F-7875-4030-9381-8BD8C4F21935}" type="datetimeFigureOut">
               <a:rPr lang="en-US" smtClean="0"/>
-              <a:t>3/25/2026</a:t>
+              <a:t>3/28/2026</a:t>
             </a:fld>
             <a:endParaRPr lang="en-US" dirty="0"/>
           </a:p>
@@ -11070,7 +11070,7 @@
           <a:p>
             <a:fld id="{D57F1E4F-1CFF-5643-939E-02111984F565}" type="slidenum">
               <a:rPr lang="en-US" smtClean="0"/>
-              <a:t>‹#›</a:t>
+              <a:t>‹nº›</a:t>
             </a:fld>
             <a:endParaRPr lang="en-US" dirty="0"/>
           </a:p>
@@ -11147,7 +11147,7 @@
           <a:p>
             <a:fld id="{4509A250-FF31-4206-8172-F9D3106AACB1}" type="datetimeFigureOut">
               <a:rPr lang="en-US" smtClean="0"/>
-              <a:t>3/25/2026</a:t>
+              <a:t>3/28/2026</a:t>
             </a:fld>
             <a:endParaRPr lang="en-US" dirty="0"/>
           </a:p>
@@ -11189,7 +11189,7 @@
           <a:p>
             <a:fld id="{D57F1E4F-1CFF-5643-939E-02111984F565}" type="slidenum">
               <a:rPr lang="en-US" smtClean="0"/>
-              <a:t>‹#›</a:t>
+              <a:t>‹nº›</a:t>
             </a:fld>
             <a:endParaRPr lang="en-US" dirty="0"/>
           </a:p>
@@ -11243,7 +11243,7 @@
           <a:p>
             <a:fld id="{4509A250-FF31-4206-8172-F9D3106AACB1}" type="datetimeFigureOut">
               <a:rPr lang="en-US" smtClean="0"/>
-              <a:t>3/25/2026</a:t>
+              <a:t>3/28/2026</a:t>
             </a:fld>
             <a:endParaRPr lang="en-US" dirty="0"/>
           </a:p>
@@ -11285,7 +11285,7 @@
           <a:p>
             <a:fld id="{D57F1E4F-1CFF-5643-939E-02111984F565}" type="slidenum">
               <a:rPr lang="en-US" smtClean="0"/>
-              <a:t>‹#›</a:t>
+              <a:t>‹nº›</a:t>
             </a:fld>
             <a:endParaRPr lang="en-US" dirty="0"/>
           </a:p>
@@ -11517,7 +11517,7 @@
           <a:p>
             <a:fld id="{4509A250-FF31-4206-8172-F9D3106AACB1}" type="datetimeFigureOut">
               <a:rPr lang="en-US" smtClean="0"/>
-              <a:t>3/25/2026</a:t>
+              <a:t>3/28/2026</a:t>
             </a:fld>
             <a:endParaRPr lang="en-US" dirty="0"/>
           </a:p>
@@ -11559,7 +11559,7 @@
           <a:p>
             <a:fld id="{D57F1E4F-1CFF-5643-939E-02111984F565}" type="slidenum">
               <a:rPr lang="en-US" smtClean="0"/>
-              <a:t>‹#›</a:t>
+              <a:t>‹nº›</a:t>
             </a:fld>
             <a:endParaRPr lang="en-US" dirty="0"/>
           </a:p>
@@ -11799,7 +11799,7 @@
           <a:p>
             <a:fld id="{4509A250-FF31-4206-8172-F9D3106AACB1}" type="datetimeFigureOut">
               <a:rPr lang="en-US" smtClean="0"/>
-              <a:t>3/25/2026</a:t>
+              <a:t>3/28/2026</a:t>
             </a:fld>
             <a:endParaRPr lang="en-US" dirty="0"/>
           </a:p>
@@ -11841,7 +11841,7 @@
           <a:p>
             <a:fld id="{D57F1E4F-1CFF-5643-939E-02111984F565}" type="slidenum">
               <a:rPr lang="en-US" smtClean="0"/>
-              <a:t>‹#›</a:t>
+              <a:t>‹nº›</a:t>
             </a:fld>
             <a:endParaRPr lang="en-US" dirty="0"/>
           </a:p>
@@ -12040,7 +12040,7 @@
           <a:p>
             <a:fld id="{4AAD347D-5ACD-4C99-B74B-A9C85AD731AF}" type="datetimeFigureOut">
               <a:rPr lang="en-US" smtClean="0"/>
-              <a:t>3/25/2026</a:t>
+              <a:t>3/28/2026</a:t>
             </a:fld>
             <a:endParaRPr lang="en-US" dirty="0"/>
           </a:p>
@@ -12154,7 +12154,7 @@
           <a:p>
             <a:fld id="{D57F1E4F-1CFF-5643-939E-02111984F565}" type="slidenum">
               <a:rPr lang="en-US" smtClean="0"/>
-              <a:t>‹#›</a:t>
+              <a:t>‹nº›</a:t>
             </a:fld>
             <a:endParaRPr lang="en-US" dirty="0"/>
           </a:p>
@@ -12779,7 +12779,7 @@
           <a:p>
             <a:fld id="{4AAD347D-5ACD-4C99-B74B-A9C85AD731AF}" type="datetimeFigureOut">
               <a:rPr lang="en-US" smtClean="0"/>
-              <a:t>3/25/2026</a:t>
+              <a:t>3/28/2026</a:t>
             </a:fld>
             <a:endParaRPr lang="en-US" dirty="0"/>
           </a:p>
@@ -12853,7 +12853,7 @@
           <a:p>
             <a:fld id="{D57F1E4F-1CFF-5643-939E-02111984F565}" type="slidenum">
               <a:rPr lang="en-US" smtClean="0"/>
-              <a:t>‹#›</a:t>
+              <a:t>‹nº›</a:t>
             </a:fld>
             <a:endParaRPr lang="en-US" dirty="0"/>
           </a:p>
@@ -13982,29 +13982,7 @@
                 <a:ea typeface="Calibri"/>
                 <a:cs typeface="Calibri"/>
               </a:rPr>
-              <a:t>Let's take a look at some samples from the dataset which feature the same </a:t>
-            </a:r>
-            <a:r>
-              <a:rPr lang="en-US" sz="1200" dirty="0" err="1">
-                <a:solidFill>
-                  <a:schemeClr val="bg1"/>
-                </a:solidFill>
-                <a:latin typeface="Calibri"/>
-                <a:ea typeface="Calibri"/>
-                <a:cs typeface="Calibri"/>
-              </a:rPr>
-              <a:t>pokemon</a:t>
-            </a:r>
-            <a:r>
-              <a:rPr lang="en-US" sz="1200" dirty="0">
-                <a:solidFill>
-                  <a:schemeClr val="bg1"/>
-                </a:solidFill>
-                <a:latin typeface="Calibri"/>
-                <a:ea typeface="Calibri"/>
-                <a:cs typeface="Calibri"/>
-              </a:rPr>
-              <a:t> </a:t>
+              <a:t>Let's take a look at some samples from the dataset which feature the same Pokémon </a:t>
             </a:r>
             <a:r>
               <a:rPr lang="en-US" sz="1200" b="1" dirty="0">
@@ -14020,7 +13998,7 @@
               </a:rPr>
               <a:t> </a:t>
             </a:r>
-            <a:endParaRPr lang="en-US" sz="1200">
+            <a:endParaRPr lang="en-US" sz="1200" dirty="0">
               <a:solidFill>
                 <a:schemeClr val="accent2">
                   <a:lumMod val="40000"/>
@@ -14312,51 +14290,7 @@
                 <a:ea typeface="Calibri"/>
                 <a:cs typeface="Calibri"/>
               </a:rPr>
-              <a:t>From this small set of examples we can see that the </a:t>
-            </a:r>
-            <a:r>
-              <a:rPr lang="en-US" sz="1200" dirty="0" err="1">
-                <a:solidFill>
-                  <a:srgbClr val="0D1B2A"/>
-                </a:solidFill>
-                <a:latin typeface="Calibri"/>
-                <a:ea typeface="Calibri"/>
-                <a:cs typeface="Calibri"/>
-              </a:rPr>
-              <a:t>pokemon</a:t>
-            </a:r>
-            <a:r>
-              <a:rPr lang="en-US" sz="1200" dirty="0">
-                <a:solidFill>
-                  <a:srgbClr val="0D1B2A"/>
-                </a:solidFill>
-                <a:latin typeface="Calibri"/>
-                <a:ea typeface="Calibri"/>
-                <a:cs typeface="Calibri"/>
-              </a:rPr>
-              <a:t> always remains in the same upright position, facing the same direction, with the same </a:t>
-            </a:r>
-            <a:r>
-              <a:rPr lang="en-US" sz="1200" dirty="0" err="1">
-                <a:solidFill>
-                  <a:srgbClr val="0D1B2A"/>
-                </a:solidFill>
-                <a:latin typeface="Calibri"/>
-                <a:ea typeface="Calibri"/>
-                <a:cs typeface="Calibri"/>
-              </a:rPr>
-              <a:t>colours</a:t>
-            </a:r>
-            <a:r>
-              <a:rPr lang="en-US" sz="1200" dirty="0">
-                <a:solidFill>
-                  <a:srgbClr val="0D1B2A"/>
-                </a:solidFill>
-                <a:latin typeface="Calibri"/>
-                <a:ea typeface="Calibri"/>
-                <a:cs typeface="Calibri"/>
-              </a:rPr>
-              <a:t>, … and the only thing that changes are: its position in the picture, and the background. Since CNNs are invariant to the object's position in the picture, in reality, the only thing that really changes is the background. So, if we replace a training example that has all these characteristics with a flipped image of </a:t>
+              <a:t>From this small set of examples, we can see that the Pokémon always remains in the same upright position, facing the same direction, with the same colors, … and the only thing that changes are: its position in the picture, and the background. Since CNNs are invariant to the object's position in the picture, in reality, the only thing that really changes is the background. So, if we replace a training example that has all these characteristics with a flipped image of </a:t>
             </a:r>
             <a:r>
               <a:rPr lang="en-US" sz="1200" dirty="0" err="1">
@@ -14400,10 +14334,13 @@
                 <a:ea typeface="Calibri"/>
                 <a:cs typeface="Calibri"/>
               </a:rPr>
-              <a:t>/test time by adding unnecessary noise, which hurts our model's performance (specially in the case of </a:t>
-            </a:r>
-            <a:r>
-              <a:rPr lang="en-US" sz="1200" dirty="0" err="1">
+              <a:t>/test time by adding unnecessary noise, which hurts our model's performance (specially in the case of color changes and grayscale since, as explored in task 1, the color is one of the dominant factors in identifying a Pokémon's type).</a:t>
+            </a:r>
+          </a:p>
+          <a:p>
+            <a:pPr algn="ctr"/>
+            <a:r>
+              <a:rPr lang="en-US" sz="1200" dirty="0">
                 <a:solidFill>
                   <a:srgbClr val="0D1B2A"/>
                 </a:solidFill>
@@ -14411,98 +14348,7 @@
                 <a:ea typeface="Calibri"/>
                 <a:cs typeface="Calibri"/>
               </a:rPr>
-              <a:t>colour</a:t>
-            </a:r>
-            <a:r>
-              <a:rPr lang="en-US" sz="1200" dirty="0">
-                <a:solidFill>
-                  <a:srgbClr val="0D1B2A"/>
-                </a:solidFill>
-                <a:latin typeface="Calibri"/>
-                <a:ea typeface="Calibri"/>
-                <a:cs typeface="Calibri"/>
-              </a:rPr>
-              <a:t> changes and grayscale since, as explored in task 1, the </a:t>
-            </a:r>
-            <a:r>
-              <a:rPr lang="en-US" sz="1200" dirty="0" err="1">
-                <a:solidFill>
-                  <a:srgbClr val="0D1B2A"/>
-                </a:solidFill>
-                <a:latin typeface="Calibri"/>
-                <a:ea typeface="Calibri"/>
-                <a:cs typeface="Calibri"/>
-              </a:rPr>
-              <a:t>colour</a:t>
-            </a:r>
-            <a:r>
-              <a:rPr lang="en-US" sz="1200" dirty="0">
-                <a:solidFill>
-                  <a:srgbClr val="0D1B2A"/>
-                </a:solidFill>
-                <a:latin typeface="Calibri"/>
-                <a:ea typeface="Calibri"/>
-                <a:cs typeface="Calibri"/>
-              </a:rPr>
-              <a:t> is one of the dominant factors in identifying a </a:t>
-            </a:r>
-            <a:r>
-              <a:rPr lang="en-US" sz="1200" dirty="0" err="1">
-                <a:solidFill>
-                  <a:srgbClr val="0D1B2A"/>
-                </a:solidFill>
-                <a:latin typeface="Calibri"/>
-                <a:ea typeface="Calibri"/>
-                <a:cs typeface="Calibri"/>
-              </a:rPr>
-              <a:t>pokemon's</a:t>
-            </a:r>
-            <a:r>
-              <a:rPr lang="en-US" sz="1200" dirty="0">
-                <a:solidFill>
-                  <a:srgbClr val="0D1B2A"/>
-                </a:solidFill>
-                <a:latin typeface="Calibri"/>
-                <a:ea typeface="Calibri"/>
-                <a:cs typeface="Calibri"/>
-              </a:rPr>
-              <a:t> type).</a:t>
-            </a:r>
-          </a:p>
-          <a:p>
-            <a:pPr algn="ctr"/>
-            <a:r>
-              <a:rPr lang="en-US" sz="1200" dirty="0">
-                <a:solidFill>
-                  <a:srgbClr val="0D1B2A"/>
-                </a:solidFill>
-                <a:latin typeface="Calibri"/>
-                <a:ea typeface="Calibri"/>
-                <a:cs typeface="Calibri"/>
-              </a:rPr>
-              <a:t>Even though we're not trying to identify the </a:t>
-            </a:r>
-            <a:r>
-              <a:rPr lang="en-US" sz="1200" dirty="0" err="1">
-                <a:solidFill>
-                  <a:srgbClr val="0D1B2A"/>
-                </a:solidFill>
-                <a:latin typeface="Calibri"/>
-                <a:ea typeface="Calibri"/>
-                <a:cs typeface="Calibri"/>
-              </a:rPr>
-              <a:t>pokemon</a:t>
-            </a:r>
-            <a:r>
-              <a:rPr lang="en-US" sz="1200" dirty="0">
-                <a:solidFill>
-                  <a:srgbClr val="0D1B2A"/>
-                </a:solidFill>
-                <a:latin typeface="Calibri"/>
-                <a:ea typeface="Calibri"/>
-                <a:cs typeface="Calibri"/>
-              </a:rPr>
-              <a:t> itself, but its type, this reasoning can be applied.</a:t>
+              <a:t>Even though we're not trying to identify the Pokémon itself, but its type, this reasoning can be applied.</a:t>
             </a:r>
           </a:p>
         </p:txBody>
@@ -15992,7 +15838,7 @@
               <a:buNone/>
             </a:pPr>
             <a:r>
-              <a:rPr lang="en-US" sz="1400" b="1">
+              <a:rPr lang="en-US" sz="1400" b="1" dirty="0">
                 <a:solidFill>
                   <a:srgbClr val="C0392B"/>
                 </a:solidFill>
@@ -16006,7 +15852,7 @@
               <a:buChar char="✗"/>
             </a:pPr>
             <a:r>
-              <a:rPr lang="en-US" sz="1100" b="1">
+              <a:rPr lang="en-US" sz="1100" b="1" dirty="0">
                 <a:solidFill>
                   <a:srgbClr val="C0392B"/>
                 </a:solidFill>
@@ -16039,29 +15885,7 @@
                 <a:ea typeface="Calibri"/>
                 <a:cs typeface="Calibri"/>
               </a:rPr>
-              <a:t>0.0149 F1; the </a:t>
-            </a:r>
-            <a:r>
-              <a:rPr lang="en-US" sz="1000" dirty="0" err="1">
-                <a:solidFill>
-                  <a:srgbClr val="1A2B3C"/>
-                </a:solidFill>
-                <a:latin typeface="Calibri"/>
-                <a:ea typeface="Calibri"/>
-                <a:cs typeface="Calibri"/>
-              </a:rPr>
-              <a:t>pokemons</a:t>
-            </a:r>
-            <a:r>
-              <a:rPr lang="en-US" sz="1000" dirty="0">
-                <a:solidFill>
-                  <a:srgbClr val="1A2B3C"/>
-                </a:solidFill>
-                <a:latin typeface="Calibri"/>
-                <a:ea typeface="Calibri"/>
-                <a:cs typeface="Calibri"/>
-              </a:rPr>
-              <a:t> are always the same way, the only thing that changes are the background at the position; CNNs are translation invariant so the only real thing that changes for our network is the background. The more aggressive the augmentation is the bigger the decay in performance</a:t>
+              <a:t>0.0149 F1; the Pokémons are always the same way, the only thing that changes are the background at the position; CNNs are translation invariant so the only real thing that changes for our network is the background. The more aggressive the augmentation is the bigger the decay in performance</a:t>
             </a:r>
           </a:p>
           <a:p>
@@ -16069,7 +15893,7 @@
               <a:buChar char="✗"/>
             </a:pPr>
             <a:r>
-              <a:rPr lang="en-US" sz="1100" b="1">
+              <a:rPr lang="en-US" sz="1100" b="1" dirty="0">
                 <a:solidFill>
                   <a:srgbClr val="C0392B"/>
                 </a:solidFill>
@@ -16079,14 +15903,6 @@
               </a:rPr>
               <a:t>Many FC layers</a:t>
             </a:r>
-            <a:endParaRPr lang="en-US" sz="1100" b="1" dirty="0">
-              <a:solidFill>
-                <a:srgbClr val="C0392B"/>
-              </a:solidFill>
-              <a:latin typeface="Calibri"/>
-              <a:ea typeface="Calibri"/>
-              <a:cs typeface="Calibri"/>
-            </a:endParaRPr>
           </a:p>
           <a:p>
             <a:pPr lvl="1"/>
@@ -16099,29 +15915,7 @@
                 <a:ea typeface="Calibri"/>
                 <a:cs typeface="Calibri"/>
               </a:rPr>
-              <a:t>- 3 or more FC layers starts giving us a slower training and </a:t>
-            </a:r>
-            <a:r>
-              <a:rPr lang="en-US" sz="1000">
-                <a:solidFill>
-                  <a:srgbClr val="1A2B3C"/>
-                </a:solidFill>
-                <a:latin typeface="Calibri"/>
-                <a:ea typeface="Calibri"/>
-                <a:cs typeface="Calibri"/>
-              </a:rPr>
-              <a:t>worse results (parameters increase a lot if our convolution channels are wide); keep it simple and </a:t>
-            </a:r>
-            <a:r>
-              <a:rPr lang="en-US" sz="1000" dirty="0">
-                <a:solidFill>
-                  <a:srgbClr val="1A2B3C"/>
-                </a:solidFill>
-                <a:latin typeface="Calibri"/>
-                <a:ea typeface="Calibri"/>
-                <a:cs typeface="Calibri"/>
-              </a:rPr>
-              <a:t>let convolutional layers learn the information, then pass them to minimal FC layers</a:t>
+              <a:t>- 3 or more FC layers starts giving us a slower training and worse results (parameters increase a lot if our convolution channels are wide); keep it simple and let convolutional layers learn the information, then pass them to minimal FC layers</a:t>
             </a:r>
           </a:p>
           <a:p>
@@ -16190,7 +15984,7 @@
               <a:buChar char="✗"/>
             </a:pPr>
             <a:r>
-              <a:rPr lang="en-US" sz="1100" b="1">
+              <a:rPr lang="en-US" sz="1100" b="1" dirty="0">
                 <a:solidFill>
                   <a:srgbClr val="C0392B"/>
                 </a:solidFill>
@@ -16200,7 +15994,7 @@
               </a:rPr>
               <a:t>Ensembles</a:t>
             </a:r>
-            <a:endParaRPr lang="en-US" sz="1100" b="1">
+            <a:endParaRPr lang="en-US" sz="1100" b="1" dirty="0">
               <a:solidFill>
                 <a:srgbClr val="C0392B"/>
               </a:solidFill>
@@ -16231,29 +16025,7 @@
                 <a:ea typeface="Calibri"/>
                 <a:cs typeface="Calibri"/>
               </a:rPr>
-              <a:t>Ensembled models </a:t>
-            </a:r>
-            <a:r>
-              <a:rPr lang="en-US" sz="1000">
-                <a:solidFill>
-                  <a:srgbClr val="1A2B3C"/>
-                </a:solidFill>
-                <a:latin typeface="Calibri"/>
-                <a:ea typeface="Calibri"/>
-                <a:cs typeface="Calibri"/>
-              </a:rPr>
-              <a:t>could not</a:t>
-            </a:r>
-            <a:r>
-              <a:rPr lang="en-US" sz="1000" dirty="0">
-                <a:solidFill>
-                  <a:srgbClr val="1A2B3C"/>
-                </a:solidFill>
-                <a:latin typeface="Calibri"/>
-                <a:ea typeface="Calibri"/>
-                <a:cs typeface="Calibri"/>
-              </a:rPr>
-              <a:t> achieve a better performance</a:t>
+              <a:t>Ensembled models could not achieve a better performance</a:t>
             </a:r>
           </a:p>
           <a:p>
@@ -16261,7 +16033,7 @@
               <a:buChar char="✗"/>
             </a:pPr>
             <a:r>
-              <a:rPr lang="en-US" sz="1100" b="1">
+              <a:rPr lang="en-US" sz="1100" b="1" dirty="0">
                 <a:solidFill>
                   <a:srgbClr val="C0392B"/>
                 </a:solidFill>
@@ -16271,14 +16043,6 @@
               </a:rPr>
               <a:t>Label Smoothing</a:t>
             </a:r>
-            <a:endParaRPr lang="en-US" sz="1100" b="1" dirty="0">
-              <a:solidFill>
-                <a:srgbClr val="C0392B"/>
-              </a:solidFill>
-              <a:latin typeface="Calibri"/>
-              <a:ea typeface="Calibri"/>
-              <a:cs typeface="Calibri"/>
-            </a:endParaRPr>
           </a:p>
           <a:p>
             <a:pPr lvl="1"/>
@@ -16294,7 +16058,7 @@
               <a:t>- </a:t>
             </a:r>
             <a:r>
-              <a:rPr lang="en-US" sz="1000">
+              <a:rPr lang="en-US" sz="1000" dirty="0">
                 <a:solidFill>
                   <a:srgbClr val="1A2B3C"/>
                 </a:solidFill>
@@ -16757,7 +16521,7 @@
           <a:lstStyle/>
           <a:p>
             <a:r>
-              <a:rPr lang="en-US" sz="1300" b="1">
+              <a:rPr lang="en-US" sz="1300" b="1" dirty="0">
                 <a:solidFill>
                   <a:srgbClr val="00A896"/>
                 </a:solidFill>
@@ -16810,59 +16574,23 @@
                 <a:ea typeface="Calibri"/>
                 <a:cs typeface="Calibri"/>
               </a:rPr>
-              <a:t>This problem screams CNN! The dataset has images, In which the </a:t>
-            </a:r>
-            <a:r>
-              <a:rPr lang="en-US" sz="1100" dirty="0" err="1">
-                <a:solidFill>
-                  <a:schemeClr val="bg1"/>
+              <a:t>This problem screams CNN! The dataset has images, In which the Pokémons always appear in the same way, only changing their position and the background: CNNs are invariant to translations! MLPs lose all sense of spatial structure</a:t>
+            </a:r>
+          </a:p>
+          <a:p>
+            <a:r>
+              <a:rPr lang="en-US" sz="1100" b="1" dirty="0">
+                <a:solidFill>
+                  <a:schemeClr val="accent2">
+                    <a:lumMod val="40000"/>
+                    <a:lumOff val="60000"/>
+                  </a:schemeClr>
                 </a:solidFill>
                 <a:latin typeface="Calibri"/>
                 <a:ea typeface="Calibri"/>
                 <a:cs typeface="Calibri"/>
               </a:rPr>
-              <a:t>pokemons</a:t>
-            </a:r>
-            <a:r>
-              <a:rPr lang="en-US" sz="1100" dirty="0">
-                <a:solidFill>
-                  <a:schemeClr val="bg1"/>
-                </a:solidFill>
-                <a:latin typeface="Calibri"/>
-                <a:ea typeface="Calibri"/>
-                <a:cs typeface="Calibri"/>
-              </a:rPr>
-              <a:t> always appear in the same way, only changing their position and the background: CNNs are invariant to translations! MLPs lose all sense of spatial structure</a:t>
-            </a:r>
-          </a:p>
-          <a:p>
-            <a:r>
-              <a:rPr lang="en-US" sz="1100" b="1" dirty="0">
-                <a:solidFill>
-                  <a:schemeClr val="accent2">
-                    <a:lumMod val="40000"/>
-                    <a:lumOff val="60000"/>
-                  </a:schemeClr>
-                </a:solidFill>
-                <a:latin typeface="Calibri"/>
-                <a:ea typeface="Calibri"/>
-                <a:cs typeface="Calibri"/>
-              </a:rPr>
-              <a:t>Next: Transfer Learning and Fine-Tuning (Task 3) - can we achieve the </a:t>
-            </a:r>
-            <a:r>
-              <a:rPr lang="en-US" sz="1100" b="1">
-                <a:solidFill>
-                  <a:schemeClr val="accent2">
-                    <a:lumMod val="40000"/>
-                    <a:lumOff val="60000"/>
-                  </a:schemeClr>
-                </a:solidFill>
-                <a:latin typeface="Calibri"/>
-                <a:ea typeface="Calibri"/>
-                <a:cs typeface="Calibri"/>
-              </a:rPr>
-              <a:t>same performance by replacing the classifier head of a pretrained model?</a:t>
+              <a:t>Next: Transfer Learning and Fine-Tuning (Task 3) - can we achieve the same performance by replacing the classifier head of a pretrained model?</a:t>
             </a:r>
           </a:p>
         </p:txBody>
@@ -27979,79 +27707,7 @@
                 </a:solidFill>
                 <a:latin typeface="Calibri"/>
               </a:rPr>
-              <a:t>as in MLPs there's high F1 in Fire/Poison/Water, due to the distinctive </a:t>
-            </a:r>
-            <a:r>
-              <a:rPr lang="en-US" sz="1200" dirty="0" err="1">
-                <a:solidFill>
-                  <a:srgbClr val="AACCD8"/>
-                </a:solidFill>
-                <a:latin typeface="Calibri"/>
-              </a:rPr>
-              <a:t>colours</a:t>
-            </a:r>
-            <a:r>
-              <a:rPr lang="en-US" sz="1200" dirty="0">
-                <a:solidFill>
-                  <a:srgbClr val="AACCD8"/>
-                </a:solidFill>
-                <a:latin typeface="Calibri"/>
-              </a:rPr>
-              <a:t> of these types; shared palette or humanoid shape give us low F1 (Bug/Rock/Fighting/Ground), since they have no predominant </a:t>
-            </a:r>
-            <a:r>
-              <a:rPr lang="en-US" sz="1200" dirty="0" err="1">
-                <a:solidFill>
-                  <a:srgbClr val="AACCD8"/>
-                </a:solidFill>
-                <a:latin typeface="Calibri"/>
-              </a:rPr>
-              <a:t>colours</a:t>
-            </a:r>
-            <a:r>
-              <a:rPr lang="en-US" sz="1200" dirty="0">
-                <a:solidFill>
-                  <a:srgbClr val="AACCD8"/>
-                </a:solidFill>
-                <a:latin typeface="Calibri"/>
-              </a:rPr>
-              <a:t>. These models had more difficulty making the jump from the </a:t>
-            </a:r>
-            <a:r>
-              <a:rPr lang="en-US" sz="1200" dirty="0" err="1">
-                <a:solidFill>
-                  <a:srgbClr val="AACCD8"/>
-                </a:solidFill>
-                <a:latin typeface="Calibri"/>
-              </a:rPr>
-              <a:t>colours</a:t>
-            </a:r>
-            <a:r>
-              <a:rPr lang="en-US" sz="1200" dirty="0">
-                <a:solidFill>
-                  <a:srgbClr val="AACCD8"/>
-                </a:solidFill>
-                <a:latin typeface="Calibri"/>
-              </a:rPr>
-              <a:t> to the shapes of the </a:t>
-            </a:r>
-            <a:r>
-              <a:rPr lang="en-US" sz="1200" dirty="0" err="1">
-                <a:solidFill>
-                  <a:srgbClr val="AACCD8"/>
-                </a:solidFill>
-                <a:latin typeface="Calibri"/>
-              </a:rPr>
-              <a:t>pokemon</a:t>
-            </a:r>
-            <a:r>
-              <a:rPr lang="en-US" sz="1200" dirty="0">
-                <a:solidFill>
-                  <a:srgbClr val="AACCD8"/>
-                </a:solidFill>
-                <a:latin typeface="Calibri"/>
-              </a:rPr>
-              <a:t> themselves</a:t>
+              <a:t>as in MLPs there's high F1 in Fire/Poison/Water, due to the distinctive colors of these types; shared palette or humanoid shape give us low F1 (Bug/Rock/Fighting/Ground), since they have no predominant colors. These models had more difficulty making the jump from the colors to the shapes of the Pokémon themselves</a:t>
             </a:r>
             <a:endParaRPr lang="en-US" sz="1200" dirty="0">
               <a:solidFill>
@@ -30975,7 +30631,7 @@
           <a:lstStyle/>
           <a:p>
             <a:r>
-              <a:rPr lang="en-US" sz="1200" b="1">
+              <a:rPr lang="en-US" sz="1200" b="1" dirty="0">
                 <a:solidFill>
                   <a:srgbClr val="00A896"/>
                 </a:solidFill>
@@ -30983,7 +30639,7 @@
               </a:rPr>
               <a:t>Normal is the catch-all for MLP</a:t>
             </a:r>
-            <a:endParaRPr lang="en-US"/>
+            <a:endParaRPr lang="en-US" dirty="0"/>
           </a:p>
           <a:p>
             <a:pPr marL="228600" indent="-228600">
@@ -30996,18 +30652,9 @@
                 </a:solidFill>
                 <a:latin typeface="Calibri"/>
               </a:rPr>
-              <a:t>Normal = most diverse class: humanoids of every shape and size, no dominant </a:t>
-            </a:r>
-            <a:r>
-              <a:rPr lang="en-US" sz="1100" dirty="0" err="1">
-                <a:solidFill>
-                  <a:schemeClr val="bg1"/>
-                </a:solidFill>
-                <a:latin typeface="Calibri"/>
-              </a:rPr>
-              <a:t>colour</a:t>
-            </a:r>
-            <a:endParaRPr lang="en-US" sz="1100" dirty="0" err="1">
+              <a:t>Normal = most diverse class: humanoids of every shape and size, no dominant color</a:t>
+            </a:r>
+            <a:endParaRPr lang="en-US" sz="1100" dirty="0">
               <a:solidFill>
                 <a:schemeClr val="bg1"/>
               </a:solidFill>
@@ -31202,7 +30849,7 @@
           <a:lstStyle/>
           <a:p>
             <a:r>
-              <a:rPr lang="en-US" sz="1200" b="1">
+              <a:rPr lang="en-US" sz="1200" b="1" dirty="0">
                 <a:solidFill>
                   <a:srgbClr val="00A896"/>
                 </a:solidFill>
@@ -31210,7 +30857,7 @@
               </a:rPr>
               <a:t>CNNs are immune to this</a:t>
             </a:r>
-            <a:endParaRPr lang="en-US"/>
+            <a:endParaRPr lang="en-US" dirty="0"/>
           </a:p>
           <a:p>
             <a:pPr marL="228600" indent="-228600">
@@ -31226,29 +30873,7 @@
                 <a:ea typeface="Calibri"/>
                 <a:cs typeface="Calibri"/>
               </a:rPr>
-              <a:t>As stated before, they can learn other patterns besides </a:t>
-            </a:r>
-            <a:r>
-              <a:rPr lang="en-US" sz="1100" dirty="0" err="1">
-                <a:solidFill>
-                  <a:schemeClr val="bg1"/>
-                </a:solidFill>
-                <a:latin typeface="Calibri"/>
-                <a:ea typeface="Calibri"/>
-                <a:cs typeface="Calibri"/>
-              </a:rPr>
-              <a:t>colour</a:t>
-            </a:r>
-            <a:r>
-              <a:rPr lang="en-US" sz="1100" dirty="0">
-                <a:solidFill>
-                  <a:schemeClr val="bg1"/>
-                </a:solidFill>
-                <a:latin typeface="Calibri"/>
-                <a:ea typeface="Calibri"/>
-                <a:cs typeface="Calibri"/>
-              </a:rPr>
-              <a:t> and independent pixels</a:t>
+              <a:t>As stated before, they can learn other patterns besides color and independent pixels</a:t>
             </a:r>
           </a:p>
         </p:txBody>
@@ -42324,7 +41949,7 @@
               <a:buNone/>
             </a:pPr>
             <a:r>
-              <a:rPr lang="en-US" sz="1400" b="1">
+              <a:rPr lang="en-US" sz="1400" b="1" dirty="0">
                 <a:solidFill>
                   <a:srgbClr val="00A896"/>
                 </a:solidFill>
@@ -42335,7 +41960,7 @@
           </a:p>
           <a:p>
             <a:r>
-              <a:rPr lang="en-US" sz="1100" b="1">
+              <a:rPr lang="en-US" sz="1100" b="1" dirty="0">
                 <a:solidFill>
                   <a:srgbClr val="1C3A52"/>
                 </a:solidFill>
@@ -42345,7 +41970,7 @@
               </a:rPr>
               <a:t>Decreased effectiveness when compared to MLPs. Idea:</a:t>
             </a:r>
-            <a:endParaRPr lang="en-US" sz="1100" b="1">
+            <a:endParaRPr lang="en-US" sz="1100" b="1" dirty="0">
               <a:solidFill>
                 <a:srgbClr val="1C3A52"/>
               </a:solidFill>
@@ -42367,10 +41992,29 @@
                 <a:ea typeface="Calibri"/>
                 <a:cs typeface="Calibri"/>
               </a:rPr>
-              <a:t>Softens hard one-hot targets </a:t>
-            </a:r>
-            <a:r>
-              <a:rPr lang="en-US" sz="1100">
+              <a:t>Softens hard one-hot targets (0.9/0.1 blend vs 1.0 hard)</a:t>
+            </a:r>
+          </a:p>
+          <a:p>
+            <a:pPr marL="228600" indent="-228600">
+              <a:buChar char="•"/>
+            </a:pPr>
+            <a:r>
+              <a:rPr lang="en-US" sz="1100" dirty="0">
+                <a:solidFill>
+                  <a:srgbClr val="1A2B3C"/>
+                </a:solidFill>
+                <a:latin typeface="Calibri" pitchFamily="34" charset="0"/>
+              </a:rPr>
+              <a:t>Prevents overconfident predictions on visually ambiguous classes</a:t>
+            </a:r>
+          </a:p>
+          <a:p>
+            <a:pPr marL="228600" indent="-228600">
+              <a:buChar char="•"/>
+            </a:pPr>
+            <a:r>
+              <a:rPr lang="en-US" sz="1100" dirty="0">
                 <a:solidFill>
                   <a:srgbClr val="1A2B3C"/>
                 </a:solidFill>
@@ -42378,67 +42022,15 @@
                 <a:ea typeface="Calibri"/>
                 <a:cs typeface="Calibri"/>
               </a:rPr>
-              <a:t>(0.9/0.1 blend vs 1.0 hard)</a:t>
-            </a:r>
-          </a:p>
-          <a:p>
-            <a:pPr marL="228600" indent="-228600">
-              <a:buChar char="•"/>
+              <a:t>Key on noisy boundaries — Bug/Grass and Rock/Ground share color palettes</a:t>
+            </a:r>
+          </a:p>
+          <a:p>
+            <a:pPr>
+              <a:buNone/>
             </a:pPr>
             <a:r>
-              <a:rPr lang="en-US" sz="1100" dirty="0">
-                <a:solidFill>
-                  <a:srgbClr val="1A2B3C"/>
-                </a:solidFill>
-                <a:latin typeface="Calibri" pitchFamily="34" charset="0"/>
-              </a:rPr>
-              <a:t>Prevents overconfident predictions on visually ambiguous classes</a:t>
-            </a:r>
-          </a:p>
-          <a:p>
-            <a:pPr marL="228600" indent="-228600">
-              <a:buChar char="•"/>
-            </a:pPr>
-            <a:r>
-              <a:rPr lang="en-US" sz="1100" dirty="0">
-                <a:solidFill>
-                  <a:srgbClr val="1A2B3C"/>
-                </a:solidFill>
-                <a:latin typeface="Calibri"/>
-                <a:ea typeface="Calibri"/>
-                <a:cs typeface="Calibri"/>
-              </a:rPr>
-              <a:t>Key on noisy boundaries — Bug/Grass and Rock/Ground share </a:t>
-            </a:r>
-            <a:r>
-              <a:rPr lang="en-US" sz="1100" dirty="0" err="1">
-                <a:solidFill>
-                  <a:srgbClr val="1A2B3C"/>
-                </a:solidFill>
-                <a:latin typeface="Calibri"/>
-                <a:ea typeface="Calibri"/>
-                <a:cs typeface="Calibri"/>
-              </a:rPr>
-              <a:t>colour</a:t>
-            </a:r>
-            <a:r>
-              <a:rPr lang="en-US" sz="1100" dirty="0">
-                <a:solidFill>
-                  <a:srgbClr val="1A2B3C"/>
-                </a:solidFill>
-                <a:latin typeface="Calibri"/>
-                <a:ea typeface="Calibri"/>
-                <a:cs typeface="Calibri"/>
-              </a:rPr>
-              <a:t> palettes</a:t>
-            </a:r>
-          </a:p>
-          <a:p>
-            <a:pPr>
-              <a:buNone/>
-            </a:pPr>
-            <a:r>
-              <a:rPr lang="en-US" sz="1100" b="1">
+              <a:rPr lang="en-US" sz="1100" b="1" dirty="0">
                 <a:solidFill>
                   <a:srgbClr val="1C3A52"/>
                 </a:solidFill>
@@ -42454,7 +42046,7 @@
               <a:buChar char="•"/>
             </a:pPr>
             <a:r>
-              <a:rPr lang="en-US" sz="1100">
+              <a:rPr lang="en-US" sz="1100" dirty="0">
                 <a:solidFill>
                   <a:srgbClr val="1A2B3C"/>
                 </a:solidFill>
@@ -42462,29 +42054,7 @@
                 <a:ea typeface="Calibri"/>
                 <a:cs typeface="Calibri"/>
               </a:rPr>
-              <a:t>LS=0.1 (F) = 0.9750 vs LS=0.0 </a:t>
-            </a:r>
-            <a:r>
-              <a:rPr lang="en-US" sz="1100" dirty="0">
-                <a:solidFill>
-                  <a:srgbClr val="1A2B3C"/>
-                </a:solidFill>
-                <a:latin typeface="Calibri"/>
-                <a:ea typeface="Calibri"/>
-                <a:cs typeface="Calibri"/>
-              </a:rPr>
-              <a:t>(C) = </a:t>
-            </a:r>
-            <a:r>
-              <a:rPr lang="en-US" sz="1100">
-                <a:solidFill>
-                  <a:srgbClr val="1A2B3C"/>
-                </a:solidFill>
-                <a:latin typeface="Calibri"/>
-                <a:ea typeface="Calibri"/>
-                <a:cs typeface="Calibri"/>
-              </a:rPr>
-              <a:t>0.9880 — tiny decrease</a:t>
+              <a:t>LS=0.1 (F) = 0.9750 vs LS=0.0 (C) = 0.9880 — tiny decrease</a:t>
             </a:r>
           </a:p>
           <a:p>
@@ -42507,29 +42077,7 @@
                 <a:ea typeface="Calibri"/>
                 <a:cs typeface="Calibri"/>
               </a:rPr>
-              <a:t>A lot of models can effectively </a:t>
-            </a:r>
-            <a:r>
-              <a:rPr lang="en-US" sz="1100">
-                <a:solidFill>
-                  <a:srgbClr val="1A2B3C"/>
-                </a:solidFill>
-                <a:latin typeface="Calibri"/>
-                <a:ea typeface="Calibri"/>
-                <a:cs typeface="Calibri"/>
-              </a:rPr>
-              <a:t>converge to a near-perfect validation score, adding label smoothing adds unnecessary </a:t>
-            </a:r>
-            <a:r>
-              <a:rPr lang="en-US" sz="1100" dirty="0">
-                <a:solidFill>
-                  <a:srgbClr val="1A2B3C"/>
-                </a:solidFill>
-                <a:latin typeface="Calibri"/>
-                <a:ea typeface="Calibri"/>
-                <a:cs typeface="Calibri"/>
-              </a:rPr>
-              <a:t>noise</a:t>
+              <a:t>A lot of models can effectively converge to a near-perfect validation score, adding label smoothing adds unnecessary noise</a:t>
             </a:r>
           </a:p>
         </p:txBody>
@@ -43077,22 +42625,13 @@
               <a:buNone/>
             </a:pPr>
             <a:r>
-              <a:rPr lang="en-US" sz="1400" b="1" dirty="0" err="1">
+              <a:rPr lang="en-US" sz="1400" b="1" dirty="0">
                 <a:solidFill>
                   <a:srgbClr val="028090"/>
                 </a:solidFill>
                 <a:latin typeface="Trebuchet MS"/>
               </a:rPr>
-              <a:t>Optimiser</a:t>
-            </a:r>
-            <a:r>
-              <a:rPr lang="en-US" sz="1400" b="1" dirty="0">
-                <a:solidFill>
-                  <a:srgbClr val="028090"/>
-                </a:solidFill>
-                <a:latin typeface="Trebuchet MS"/>
-              </a:rPr>
-              <a:t> + Scheduler</a:t>
+              <a:t>Optimizer + Scheduler</a:t>
             </a:r>
           </a:p>
           <a:p>
@@ -43890,54 +43429,9 @@
                 </a:solidFill>
                 <a:latin typeface="Calibri"/>
               </a:rPr>
-              <a:t>A 64x64 RGB image results in an initial vector of length = 12.288. If we convert to grayscale the size is reduced by 3, to 4096. Are we able to achieve similar results with this smaller input?  Turns out no. </a:t>
-            </a:r>
-            <a:r>
-              <a:rPr lang="en-US" sz="1300" err="1">
-                <a:solidFill>
-                  <a:srgbClr val="1A2B3C"/>
-                </a:solidFill>
-                <a:latin typeface="Calibri"/>
-              </a:rPr>
-              <a:t>Pokemon</a:t>
-            </a:r>
-            <a:r>
-              <a:rPr lang="en-US" sz="1300" dirty="0">
-                <a:solidFill>
-                  <a:srgbClr val="1A2B3C"/>
-                </a:solidFill>
-                <a:latin typeface="Calibri"/>
-              </a:rPr>
-              <a:t> classi</a:t>
-            </a:r>
-            <a:r>
-              <a:rPr lang="en-US" sz="1300" err="1">
-                <a:solidFill>
-                  <a:srgbClr val="1A2B3C"/>
-                </a:solidFill>
-                <a:latin typeface="Calibri"/>
-              </a:rPr>
-              <a:t>ficatio</a:t>
-            </a:r>
-            <a:r>
-              <a:rPr lang="en-US" sz="1300" dirty="0">
-                <a:solidFill>
-                  <a:srgbClr val="1A2B3C"/>
-                </a:solidFill>
-                <a:latin typeface="Calibri"/>
-              </a:rPr>
-              <a:t>n is strongly color-dependent (Fire=orange, water=blue, poison=purple, </a:t>
-            </a:r>
-            <a:r>
-              <a:rPr lang="en-US" sz="1300">
-                <a:solidFill>
-                  <a:srgbClr val="1A2B3C"/>
-                </a:solidFill>
-                <a:latin typeface="Calibri"/>
-              </a:rPr>
-              <a:t>grass=green, ...)</a:t>
-            </a:r>
-            <a:endParaRPr lang="en-US" sz="1300">
+              <a:t>A 64x64 RGB image results in an initial vector of length = 12.288. If we convert to grayscale the size is reduced by 3, to 4096. Are we able to achieve similar results with this smaller input?  Turns out no. Pokémon classification is strongly color-dependent (Fire=orange, water=blue, poison=purple, grass=green, ...)</a:t>
+            </a:r>
+            <a:endParaRPr lang="en-US" sz="1300" dirty="0">
               <a:solidFill>
                 <a:srgbClr val="1A2B3C"/>
               </a:solidFill>

</xml_diff>